<commit_message>
Prepare VIT team submission and test code-trained CPU retrieval
</commit_message>
<xml_diff>
--- a/docs/CodeStrata-Submission-Draft.pptx
+++ b/docs/CodeStrata-Submission-Draft.pptx
@@ -13105,7 +13105,7 @@
         <p:spPr>
           <a:xfrm>
             <a:off x="777240" y="3310128"/>
-            <a:ext cx="5852160" cy="777240"/>
+            <a:ext cx="5852160" cy="2743200"/>
           </a:xfrm>
           <a:prstGeom prst="rect">
             <a:avLst/>
@@ -13168,7 +13168,7 @@
                 </a:solidFill>
                 <a:latin typeface="Aptos"/>
               </a:rPr>
-              <a:t>Team name — [TEAM TO COMPLETE]</a:t>
+              <a:t>Team — CodeStrata</a:t>
             </a:r>
           </a:p>
           <a:p>
@@ -13185,7 +13185,7 @@
                 </a:solidFill>
                 <a:latin typeface="Aptos"/>
               </a:rPr>
-              <a:t>College — [TEAM TO COMPLETE]</a:t>
+              <a:t>Vellore Institute of Technology (VIT University)</a:t>
             </a:r>
           </a:p>
           <a:p>
@@ -13202,7 +13202,7 @@
                 </a:solidFill>
                 <a:latin typeface="Aptos"/>
               </a:rPr>
-              <a:t>Contributor — Advay [full name and email to complete]</a:t>
+              <a:t>Advay Vivek · 24BCT0136 · advay.vivek2024@vitstudent.ac.in</a:t>
             </a:r>
           </a:p>
           <a:p>
@@ -13219,7 +13219,7 @@
                 </a:solidFill>
                 <a:latin typeface="Aptos"/>
               </a:rPr>
-              <a:t>Other members — [confirm or remove]</a:t>
+              <a:t>Kaavish Gogia · 24BCT0103 · kaavish.gogia2024@vitstudent.ac.in</a:t>
             </a:r>
           </a:p>
           <a:p>
@@ -14384,106 +14384,496 @@
             <a:normAutofit/>
           </a:bodyPr>
           <a:lstStyle/>
+        </p:txBody>
+      </p:sp>
+      <p:sp>
+        <p:nvSpPr>
+          <p:cNvPr id="115" name="CodeStrata diagram 115"/>
+          <p:cNvSpPr/>
+          <p:nvPr/>
+        </p:nvSpPr>
+        <p:spPr>
+          <a:xfrm>
+            <a:off x="820000" y="2000000"/>
+            <a:ext cx="2850000" cy="820000"/>
+          </a:xfrm>
+          <a:prstGeom prst="roundRect">
+            <a:avLst/>
+          </a:prstGeom>
+          <a:solidFill>
+            <a:srgbClr val="F1EEFF"/>
+          </a:solidFill>
+          <a:ln w="12700">
+            <a:solidFill>
+              <a:srgbClr val="D9D3EE"/>
+            </a:solidFill>
+          </a:ln>
+        </p:spPr>
+        <p:txBody>
+          <a:bodyPr anchor="ctr" lIns="110000" rIns="110000"/>
+          <a:lstStyle/>
           <a:p>
-            <a:pPr>
-              <a:buNone/>
-              <a:spcAft>
-                <a:spcPts val="1200"/>
-              </a:spcAft>
+            <a:pPr algn="ctr">
+              <a:buNone/>
             </a:pPr>
             <a:r>
-              <a:rPr lang="en-US" sz="2200">
-                <a:solidFill>
-                  <a:srgbClr val="24243B"/>
-                </a:solidFill>
-                <a:latin typeface="Aptos"/>
+              <a:rPr lang="en-US" sz="1800" b="1">
+                <a:solidFill>
+                  <a:srgbClr val="33255B"/>
+                </a:solidFill>
               </a:rPr>
-              <a:t>Git snapshots → Babel AST, source comments, exact locations</a:t>
+              <a:t>Git versions</a:t>
             </a:r>
           </a:p>
+        </p:txBody>
+      </p:sp>
+      <p:sp>
+        <p:nvSpPr>
+          <p:cNvPr id="116" name="CodeStrata diagram 116"/>
+          <p:cNvSpPr/>
+          <p:nvPr/>
+        </p:nvSpPr>
+        <p:spPr>
+          <a:xfrm>
+            <a:off x="4440000" y="2000000"/>
+            <a:ext cx="2850000" cy="820000"/>
+          </a:xfrm>
+          <a:prstGeom prst="roundRect">
+            <a:avLst/>
+          </a:prstGeom>
+          <a:solidFill>
+            <a:srgbClr val="F1EEFF"/>
+          </a:solidFill>
+          <a:ln w="12700">
+            <a:solidFill>
+              <a:srgbClr val="D9D3EE"/>
+            </a:solidFill>
+          </a:ln>
+        </p:spPr>
+        <p:txBody>
+          <a:bodyPr anchor="ctr" lIns="110000" rIns="110000"/>
+          <a:lstStyle/>
           <a:p>
-            <a:pPr>
-              <a:buNone/>
-              <a:spcAft>
-                <a:spcPts val="1200"/>
-              </a:spcAft>
+            <a:pPr algn="ctr">
+              <a:buNone/>
             </a:pPr>
             <a:r>
-              <a:rPr lang="en-US" sz="2200">
-                <a:solidFill>
-                  <a:srgbClr val="24243B"/>
-                </a:solidFill>
-                <a:latin typeface="Aptos"/>
+              <a:rPr lang="en-US" sz="1800" b="1">
+                <a:solidFill>
+                  <a:srgbClr val="33255B"/>
+                </a:solidFill>
               </a:rPr>
-              <a:t>→ Cached BM25 postings + quantized CPU embedding vectors</a:t>
+              <a:t>AST behavior facts</a:t>
             </a:r>
           </a:p>
+        </p:txBody>
+      </p:sp>
+      <p:sp>
+        <p:nvSpPr>
+          <p:cNvPr id="117" name="CodeStrata diagram 117"/>
+          <p:cNvSpPr/>
+          <p:nvPr/>
+        </p:nvSpPr>
+        <p:spPr>
+          <a:xfrm>
+            <a:off x="8060000" y="2000000"/>
+            <a:ext cx="2850000" cy="820000"/>
+          </a:xfrm>
+          <a:prstGeom prst="roundRect">
+            <a:avLst/>
+          </a:prstGeom>
+          <a:solidFill>
+            <a:srgbClr val="F1EEFF"/>
+          </a:solidFill>
+          <a:ln w="12700">
+            <a:solidFill>
+              <a:srgbClr val="D9D3EE"/>
+            </a:solidFill>
+          </a:ln>
+        </p:spPr>
+        <p:txBody>
+          <a:bodyPr anchor="ctr" lIns="110000" rIns="110000"/>
+          <a:lstStyle/>
           <a:p>
-            <a:pPr>
-              <a:buNone/>
-              <a:spcAft>
-                <a:spcPts val="1200"/>
-              </a:spcAft>
+            <a:pPr algn="ctr">
+              <a:buNone/>
             </a:pPr>
             <a:r>
-              <a:rPr lang="en-US" sz="2200">
-                <a:solidFill>
-                  <a:srgbClr val="24243B"/>
-                </a:solidFill>
-                <a:latin typeface="Aptos"/>
+              <a:rPr lang="en-US" sz="1800" b="1">
+                <a:solidFill>
+                  <a:srgbClr val="33255B"/>
+                </a:solidFill>
               </a:rPr>
-              <a:t>Query → local constraint planner → fused candidate ranking</a:t>
+              <a:t>BM25 + CPU vectors</a:t>
             </a:r>
           </a:p>
+        </p:txBody>
+      </p:sp>
+      <p:sp>
+        <p:nvSpPr>
+          <p:cNvPr id="118" name="CodeStrata diagram 118"/>
+          <p:cNvSpPr/>
+          <p:nvPr/>
+        </p:nvSpPr>
+        <p:spPr>
+          <a:xfrm>
+            <a:off x="820000" y="3890000"/>
+            <a:ext cx="2850000" cy="820000"/>
+          </a:xfrm>
+          <a:prstGeom prst="roundRect">
+            <a:avLst/>
+          </a:prstGeom>
+          <a:solidFill>
+            <a:srgbClr val="EAF8F2"/>
+          </a:solidFill>
+          <a:ln w="12700">
+            <a:solidFill>
+              <a:srgbClr val="D9D3EE"/>
+            </a:solidFill>
+          </a:ln>
+        </p:spPr>
+        <p:txBody>
+          <a:bodyPr anchor="ctr" lIns="110000" rIns="110000"/>
+          <a:lstStyle/>
           <a:p>
-            <a:pPr>
-              <a:buNone/>
-              <a:spcAft>
-                <a:spcPts val="1200"/>
-              </a:spcAft>
+            <a:pPr algn="ctr">
+              <a:buNone/>
             </a:pPr>
             <a:r>
-              <a:rPr lang="en-US" sz="2200">
-                <a:solidFill>
-                  <a:srgbClr val="24243B"/>
-                </a:solidFill>
-                <a:latin typeface="Aptos"/>
+              <a:rPr lang="en-US" sz="1800" b="1">
+                <a:solidFill>
+                  <a:srgbClr val="33255B"/>
+                </a:solidFill>
               </a:rPr>
-              <a:t>→ inspect evidence → follow version/import links → bounded stop</a:t>
+              <a:t>Question + constraints</a:t>
             </a:r>
           </a:p>
+        </p:txBody>
+      </p:sp>
+      <p:sp>
+        <p:nvSpPr>
+          <p:cNvPr id="119" name="CodeStrata diagram 119"/>
+          <p:cNvSpPr/>
+          <p:nvPr/>
+        </p:nvSpPr>
+        <p:spPr>
+          <a:xfrm>
+            <a:off x="4440000" y="3890000"/>
+            <a:ext cx="2850000" cy="820000"/>
+          </a:xfrm>
+          <a:prstGeom prst="roundRect">
+            <a:avLst/>
+          </a:prstGeom>
+          <a:solidFill>
+            <a:srgbClr val="EAF8F2"/>
+          </a:solidFill>
+          <a:ln w="12700">
+            <a:solidFill>
+              <a:srgbClr val="D9D3EE"/>
+            </a:solidFill>
+          </a:ln>
+        </p:spPr>
+        <p:txBody>
+          <a:bodyPr anchor="ctr" lIns="110000" rIns="110000"/>
+          <a:lstStyle/>
           <a:p>
-            <a:pPr>
-              <a:buNone/>
-              <a:spcAft>
-                <a:spcPts val="1200"/>
-              </a:spcAft>
+            <a:pPr algn="ctr">
+              <a:buNone/>
             </a:pPr>
             <a:r>
-              <a:rPr lang="en-US" sz="2200">
-                <a:solidFill>
-                  <a:srgbClr val="24243B"/>
-                </a:solidFill>
-                <a:latin typeface="Aptos"/>
+              <a:rPr lang="en-US" sz="1800" b="1">
+                <a:solidFill>
+                  <a:srgbClr val="33255B"/>
+                </a:solidFill>
               </a:rPr>
-              <a:t>→ code + timeline + contradicting version + streamed trace</a:t>
+              <a:t>Bounded search agent</a:t>
             </a:r>
           </a:p>
+        </p:txBody>
+      </p:sp>
+      <p:sp>
+        <p:nvSpPr>
+          <p:cNvPr id="120" name="CodeStrata diagram 120"/>
+          <p:cNvSpPr/>
+          <p:nvPr/>
+        </p:nvSpPr>
+        <p:spPr>
+          <a:xfrm>
+            <a:off x="8060000" y="3890000"/>
+            <a:ext cx="2850000" cy="820000"/>
+          </a:xfrm>
+          <a:prstGeom prst="roundRect">
+            <a:avLst/>
+          </a:prstGeom>
+          <a:solidFill>
+            <a:srgbClr val="EAF8F2"/>
+          </a:solidFill>
+          <a:ln w="12700">
+            <a:solidFill>
+              <a:srgbClr val="D9D3EE"/>
+            </a:solidFill>
+          </a:ln>
+        </p:spPr>
+        <p:txBody>
+          <a:bodyPr anchor="ctr" lIns="110000" rIns="110000"/>
+          <a:lstStyle/>
           <a:p>
-            <a:pPr>
-              <a:buNone/>
-              <a:spcAft>
-                <a:spcPts val="1200"/>
-              </a:spcAft>
+            <a:pPr algn="ctr">
+              <a:buNone/>
             </a:pPr>
             <a:r>
-              <a:rPr lang="en-US" sz="2200">
-                <a:solidFill>
-                  <a:srgbClr val="24243B"/>
-                </a:solidFill>
-                <a:latin typeface="Aptos"/>
+              <a:rPr lang="en-US" sz="1800" b="1">
+                <a:solidFill>
+                  <a:srgbClr val="33255B"/>
+                </a:solidFill>
               </a:rPr>
-              <a:t>Conservative lineage: unique symbols, then mutual structural matches.</a:t>
+              <a:t>Source + counterexample</a:t>
+            </a:r>
+          </a:p>
+        </p:txBody>
+      </p:sp>
+      <p:sp>
+        <p:nvSpPr>
+          <p:cNvPr id="121" name="CodeStrata diagram 121"/>
+          <p:cNvSpPr/>
+          <p:nvPr/>
+        </p:nvSpPr>
+        <p:spPr>
+          <a:xfrm>
+            <a:off x="3670000" y="2130000"/>
+            <a:ext cx="570000" cy="530000"/>
+          </a:xfrm>
+          <a:prstGeom prst="roundRect">
+            <a:avLst/>
+          </a:prstGeom>
+          <a:solidFill>
+            <a:srgbClr val="FFFFFF"/>
+          </a:solidFill>
+          <a:ln w="12700">
+            <a:solidFill>
+              <a:srgbClr val="D9D3EE"/>
+            </a:solidFill>
+          </a:ln>
+        </p:spPr>
+        <p:txBody>
+          <a:bodyPr anchor="ctr" lIns="110000" rIns="110000"/>
+          <a:lstStyle/>
+          <a:p>
+            <a:pPr algn="ctr">
+              <a:buNone/>
+            </a:pPr>
+            <a:r>
+              <a:rPr lang="en-US" sz="2200" b="1">
+                <a:solidFill>
+                  <a:srgbClr val="33255B"/>
+                </a:solidFill>
+              </a:rPr>
+              <a:t>→</a:t>
+            </a:r>
+          </a:p>
+        </p:txBody>
+      </p:sp>
+      <p:sp>
+        <p:nvSpPr>
+          <p:cNvPr id="122" name="CodeStrata diagram 122"/>
+          <p:cNvSpPr/>
+          <p:nvPr/>
+        </p:nvSpPr>
+        <p:spPr>
+          <a:xfrm>
+            <a:off x="3670000" y="4020000"/>
+            <a:ext cx="570000" cy="530000"/>
+          </a:xfrm>
+          <a:prstGeom prst="roundRect">
+            <a:avLst/>
+          </a:prstGeom>
+          <a:solidFill>
+            <a:srgbClr val="FFFFFF"/>
+          </a:solidFill>
+          <a:ln w="12700">
+            <a:solidFill>
+              <a:srgbClr val="D9D3EE"/>
+            </a:solidFill>
+          </a:ln>
+        </p:spPr>
+        <p:txBody>
+          <a:bodyPr anchor="ctr" lIns="110000" rIns="110000"/>
+          <a:lstStyle/>
+          <a:p>
+            <a:pPr algn="ctr">
+              <a:buNone/>
+            </a:pPr>
+            <a:r>
+              <a:rPr lang="en-US" sz="2200" b="1">
+                <a:solidFill>
+                  <a:srgbClr val="33255B"/>
+                </a:solidFill>
+              </a:rPr>
+              <a:t>→</a:t>
+            </a:r>
+          </a:p>
+        </p:txBody>
+      </p:sp>
+      <p:sp>
+        <p:nvSpPr>
+          <p:cNvPr id="123" name="CodeStrata diagram 123"/>
+          <p:cNvSpPr/>
+          <p:nvPr/>
+        </p:nvSpPr>
+        <p:spPr>
+          <a:xfrm>
+            <a:off x="7290000" y="2130000"/>
+            <a:ext cx="570000" cy="530000"/>
+          </a:xfrm>
+          <a:prstGeom prst="roundRect">
+            <a:avLst/>
+          </a:prstGeom>
+          <a:solidFill>
+            <a:srgbClr val="FFFFFF"/>
+          </a:solidFill>
+          <a:ln w="12700">
+            <a:solidFill>
+              <a:srgbClr val="D9D3EE"/>
+            </a:solidFill>
+          </a:ln>
+        </p:spPr>
+        <p:txBody>
+          <a:bodyPr anchor="ctr" lIns="110000" rIns="110000"/>
+          <a:lstStyle/>
+          <a:p>
+            <a:pPr algn="ctr">
+              <a:buNone/>
+            </a:pPr>
+            <a:r>
+              <a:rPr lang="en-US" sz="2200" b="1">
+                <a:solidFill>
+                  <a:srgbClr val="33255B"/>
+                </a:solidFill>
+              </a:rPr>
+              <a:t>→</a:t>
+            </a:r>
+          </a:p>
+        </p:txBody>
+      </p:sp>
+      <p:sp>
+        <p:nvSpPr>
+          <p:cNvPr id="124" name="CodeStrata diagram 124"/>
+          <p:cNvSpPr/>
+          <p:nvPr/>
+        </p:nvSpPr>
+        <p:spPr>
+          <a:xfrm>
+            <a:off x="7290000" y="4020000"/>
+            <a:ext cx="570000" cy="530000"/>
+          </a:xfrm>
+          <a:prstGeom prst="roundRect">
+            <a:avLst/>
+          </a:prstGeom>
+          <a:solidFill>
+            <a:srgbClr val="FFFFFF"/>
+          </a:solidFill>
+          <a:ln w="12700">
+            <a:solidFill>
+              <a:srgbClr val="D9D3EE"/>
+            </a:solidFill>
+          </a:ln>
+        </p:spPr>
+        <p:txBody>
+          <a:bodyPr anchor="ctr" lIns="110000" rIns="110000"/>
+          <a:lstStyle/>
+          <a:p>
+            <a:pPr algn="ctr">
+              <a:buNone/>
+            </a:pPr>
+            <a:r>
+              <a:rPr lang="en-US" sz="2200" b="1">
+                <a:solidFill>
+                  <a:srgbClr val="33255B"/>
+                </a:solidFill>
+              </a:rPr>
+              <a:t>→</a:t>
+            </a:r>
+          </a:p>
+        </p:txBody>
+      </p:sp>
+      <p:sp>
+        <p:nvSpPr>
+          <p:cNvPr id="125" name="CodeStrata diagram 125"/>
+          <p:cNvSpPr/>
+          <p:nvPr/>
+        </p:nvSpPr>
+        <p:spPr>
+          <a:xfrm>
+            <a:off x="820000" y="3060000"/>
+            <a:ext cx="10090000" cy="530000"/>
+          </a:xfrm>
+          <a:prstGeom prst="roundRect">
+            <a:avLst/>
+          </a:prstGeom>
+          <a:solidFill>
+            <a:srgbClr val="FFFFFF"/>
+          </a:solidFill>
+          <a:ln w="12700">
+            <a:solidFill>
+              <a:srgbClr val="D9D3EE"/>
+            </a:solidFill>
+          </a:ln>
+        </p:spPr>
+        <p:txBody>
+          <a:bodyPr anchor="ctr" lIns="110000" rIns="110000"/>
+          <a:lstStyle/>
+          <a:p>
+            <a:pPr algn="ctr">
+              <a:buNone/>
+            </a:pPr>
+            <a:r>
+              <a:rPr lang="en-US" sz="1400" b="1">
+                <a:solidFill>
+                  <a:srgbClr val="33255B"/>
+                </a:solidFill>
+              </a:rPr>
+              <a:t>Lineage + import graph  ↓  evidence inspection</a:t>
+            </a:r>
+          </a:p>
+        </p:txBody>
+      </p:sp>
+      <p:sp>
+        <p:nvSpPr>
+          <p:cNvPr id="126" name="CodeStrata diagram 126"/>
+          <p:cNvSpPr/>
+          <p:nvPr/>
+        </p:nvSpPr>
+        <p:spPr>
+          <a:xfrm>
+            <a:off x="820000" y="5160000"/>
+            <a:ext cx="10090000" cy="480000"/>
+          </a:xfrm>
+          <a:prstGeom prst="roundRect">
+            <a:avLst/>
+          </a:prstGeom>
+          <a:solidFill>
+            <a:srgbClr val="F9F7FD"/>
+          </a:solidFill>
+          <a:ln w="12700">
+            <a:solidFill>
+              <a:srgbClr val="D9D3EE"/>
+            </a:solidFill>
+          </a:ln>
+        </p:spPr>
+        <p:txBody>
+          <a:bodyPr anchor="ctr" lIns="110000" rIns="110000"/>
+          <a:lstStyle/>
+          <a:p>
+            <a:pPr algn="ctr">
+              <a:buNone/>
+            </a:pPr>
+            <a:r>
+              <a:rPr lang="en-US" sz="1400" b="1">
+                <a:solidFill>
+                  <a:srgbClr val="33255B"/>
+                </a:solidFill>
+              </a:rPr>
+              <a:t>Conservative static evidence · live agent events · CPU only</a:t>
             </a:r>
           </a:p>
         </p:txBody>
@@ -14599,106 +14989,741 @@
             <a:normAutofit/>
           </a:bodyPr>
           <a:lstStyle/>
+        </p:txBody>
+      </p:sp>
+      <p:sp>
+        <p:nvSpPr>
+          <p:cNvPr id="121" name="TextBox 120"/>
+          <p:cNvSpPr txBox="1"/>
+          <p:nvPr/>
+        </p:nvSpPr>
+        <p:spPr>
+          <a:xfrm>
+            <a:off x="832104" y="1673352"/>
+            <a:ext cx="10241280" cy="338328"/>
+          </a:xfrm>
+          <a:prstGeom prst="rect">
+            <a:avLst/>
+          </a:prstGeom>
+          <a:noFill/>
+        </p:spPr>
+        <p:txBody>
+          <a:bodyPr wrap="square" lIns="36576" rIns="36576" tIns="18288" bIns="18288" anchor="ctr">
+            <a:spAutoFit/>
+          </a:bodyPr>
+          <a:lstStyle/>
           <a:p>
-            <a:pPr>
-              <a:buNone/>
-              <a:spcAft>
-                <a:spcPts val="1200"/>
-              </a:spcAft>
-            </a:pPr>
             <a:r>
-              <a:rPr lang="en-US" sz="2200">
-                <a:solidFill>
-                  <a:srgbClr val="24243B"/>
+              <a:rPr sz="1700" b="1">
+                <a:solidFill>
+                  <a:srgbClr val="6546CF"/>
                 </a:solidFill>
                 <a:latin typeface="Aptos"/>
               </a:rPr>
-              <a:t>Ask: Where did device pairing stop waiting for policyCheck?</a:t>
+              <a:t>WHERE DID DEVICE PAIRING STOP WAITING FOR policyCheck?</a:t>
             </a:r>
           </a:p>
+        </p:txBody>
+      </p:sp>
+      <p:sp>
+        <p:nvSpPr>
+          <p:cNvPr id="122" name="Rounded Rectangle 121"/>
+          <p:cNvSpPr/>
+          <p:nvPr/>
+        </p:nvSpPr>
+        <p:spPr>
+          <a:xfrm>
+            <a:off x="832104" y="2130552"/>
+            <a:ext cx="3383280" cy="987552"/>
+          </a:xfrm>
+          <a:prstGeom prst="roundRect">
+            <a:avLst/>
+          </a:prstGeom>
+          <a:solidFill>
+            <a:srgbClr val="F0EBFF"/>
+          </a:solidFill>
+          <a:ln>
+            <a:solidFill>
+              <a:srgbClr val="E2DDEF"/>
+            </a:solidFill>
+          </a:ln>
+        </p:spPr>
+        <p:style>
+          <a:lnRef idx="1">
+            <a:schemeClr val="accent1"/>
+          </a:lnRef>
+          <a:fillRef idx="3">
+            <a:schemeClr val="accent1"/>
+          </a:fillRef>
+          <a:effectRef idx="2">
+            <a:schemeClr val="accent1"/>
+          </a:effectRef>
+          <a:fontRef idx="minor">
+            <a:schemeClr val="lt1"/>
+          </a:fontRef>
+        </p:style>
+        <p:txBody>
+          <a:bodyPr rtlCol="0" anchor="ctr"/>
+          <a:lstStyle/>
           <a:p>
-            <a:pPr>
-              <a:buNone/>
-              <a:spcAft>
-                <a:spcPts val="1200"/>
-              </a:spcAft>
-            </a:pPr>
+            <a:pPr algn="ctr"/>
+          </a:p>
+        </p:txBody>
+      </p:sp>
+      <p:sp>
+        <p:nvSpPr>
+          <p:cNvPr id="123" name="TextBox 122"/>
+          <p:cNvSpPr txBox="1"/>
+          <p:nvPr/>
+        </p:nvSpPr>
+        <p:spPr>
+          <a:xfrm>
+            <a:off x="996696" y="2258568"/>
+            <a:ext cx="3035808" cy="256032"/>
+          </a:xfrm>
+          <a:prstGeom prst="rect">
+            <a:avLst/>
+          </a:prstGeom>
+          <a:noFill/>
+        </p:spPr>
+        <p:txBody>
+          <a:bodyPr wrap="square" lIns="36576" rIns="36576" tIns="18288" bIns="18288" anchor="ctr">
+            <a:spAutoFit/>
+          </a:bodyPr>
+          <a:lstStyle/>
+          <a:p>
             <a:r>
-              <a:rPr lang="en-US" sz="2200">
+              <a:rPr sz="1700" b="1">
                 <a:solidFill>
                   <a:srgbClr val="24243B"/>
                 </a:solidFill>
                 <a:latin typeface="Aptos"/>
               </a:rPr>
-              <a:t>v1: connectDevice in devices/connect.js directly awaits the call.</a:t>
+              <a:t>v1 · connectDevice</a:t>
             </a:r>
           </a:p>
+        </p:txBody>
+      </p:sp>
+      <p:sp>
+        <p:nvSpPr>
+          <p:cNvPr id="124" name="TextBox 123"/>
+          <p:cNvSpPr txBox="1"/>
+          <p:nvPr/>
+        </p:nvSpPr>
+        <p:spPr>
+          <a:xfrm>
+            <a:off x="996696" y="2633472"/>
+            <a:ext cx="3063240" cy="292608"/>
+          </a:xfrm>
+          <a:prstGeom prst="rect">
+            <a:avLst/>
+          </a:prstGeom>
+          <a:noFill/>
+        </p:spPr>
+        <p:txBody>
+          <a:bodyPr wrap="square" lIns="36576" rIns="36576" tIns="18288" bIns="18288" anchor="ctr">
+            <a:spAutoFit/>
+          </a:bodyPr>
+          <a:lstStyle/>
           <a:p>
-            <a:pPr>
-              <a:buNone/>
-              <a:spcAft>
-                <a:spcPts val="1200"/>
-              </a:spcAft>
-            </a:pPr>
             <a:r>
-              <a:rPr lang="en-US" sz="2200">
+              <a:rPr sz="1200" b="0">
                 <a:solidFill>
                   <a:srgbClr val="24243B"/>
+                </a:solidFill>
+                <a:latin typeface="Consolas"/>
+              </a:rPr>
+              <a:t>await policyCheck()  ·  devices/connect.js</a:t>
+            </a:r>
+          </a:p>
+        </p:txBody>
+      </p:sp>
+      <p:sp>
+        <p:nvSpPr>
+          <p:cNvPr id="125" name="TextBox 124"/>
+          <p:cNvSpPr txBox="1"/>
+          <p:nvPr/>
+        </p:nvSpPr>
+        <p:spPr>
+          <a:xfrm>
+            <a:off x="4297680" y="2414016"/>
+            <a:ext cx="292608" cy="347472"/>
+          </a:xfrm>
+          <a:prstGeom prst="rect">
+            <a:avLst/>
+          </a:prstGeom>
+          <a:noFill/>
+        </p:spPr>
+        <p:txBody>
+          <a:bodyPr wrap="square" lIns="36576" rIns="36576" tIns="18288" bIns="18288" anchor="ctr">
+            <a:spAutoFit/>
+          </a:bodyPr>
+          <a:lstStyle/>
+          <a:p>
+            <a:r>
+              <a:rPr sz="2000" b="1">
+                <a:solidFill>
+                  <a:srgbClr val="6546CF"/>
                 </a:solidFill>
                 <a:latin typeface="Aptos"/>
               </a:rPr>
-              <a:t>v2: pairDevice in flows/pair.js removes that await.</a:t>
+              <a:t>→</a:t>
             </a:r>
           </a:p>
+        </p:txBody>
+      </p:sp>
+      <p:sp>
+        <p:nvSpPr>
+          <p:cNvPr id="126" name="Rounded Rectangle 125"/>
+          <p:cNvSpPr/>
+          <p:nvPr/>
+        </p:nvSpPr>
+        <p:spPr>
+          <a:xfrm>
+            <a:off x="4654296" y="2130552"/>
+            <a:ext cx="3383280" cy="987552"/>
+          </a:xfrm>
+          <a:prstGeom prst="roundRect">
+            <a:avLst/>
+          </a:prstGeom>
+          <a:solidFill>
+            <a:srgbClr val="FFF2E5"/>
+          </a:solidFill>
+          <a:ln>
+            <a:solidFill>
+              <a:srgbClr val="E2DDEF"/>
+            </a:solidFill>
+          </a:ln>
+        </p:spPr>
+        <p:style>
+          <a:lnRef idx="1">
+            <a:schemeClr val="accent1"/>
+          </a:lnRef>
+          <a:fillRef idx="3">
+            <a:schemeClr val="accent1"/>
+          </a:fillRef>
+          <a:effectRef idx="2">
+            <a:schemeClr val="accent1"/>
+          </a:effectRef>
+          <a:fontRef idx="minor">
+            <a:schemeClr val="lt1"/>
+          </a:fontRef>
+        </p:style>
+        <p:txBody>
+          <a:bodyPr rtlCol="0" anchor="ctr"/>
+          <a:lstStyle/>
           <a:p>
-            <a:pPr>
-              <a:buNone/>
-              <a:spcAft>
-                <a:spcPts val="1200"/>
-              </a:spcAft>
-            </a:pPr>
+            <a:pPr algn="ctr"/>
+          </a:p>
+        </p:txBody>
+      </p:sp>
+      <p:sp>
+        <p:nvSpPr>
+          <p:cNvPr id="127" name="TextBox 126"/>
+          <p:cNvSpPr txBox="1"/>
+          <p:nvPr/>
+        </p:nvSpPr>
+        <p:spPr>
+          <a:xfrm>
+            <a:off x="4818888" y="2258568"/>
+            <a:ext cx="3035808" cy="256032"/>
+          </a:xfrm>
+          <a:prstGeom prst="rect">
+            <a:avLst/>
+          </a:prstGeom>
+          <a:noFill/>
+        </p:spPr>
+        <p:txBody>
+          <a:bodyPr wrap="square" lIns="36576" rIns="36576" tIns="18288" bIns="18288" anchor="ctr">
+            <a:spAutoFit/>
+          </a:bodyPr>
+          <a:lstStyle/>
+          <a:p>
             <a:r>
-              <a:rPr lang="en-US" sz="2200">
+              <a:rPr sz="1700" b="1">
                 <a:solidFill>
                   <a:srgbClr val="24243B"/>
                 </a:solidFill>
                 <a:latin typeface="Aptos"/>
               </a:rPr>
-              <a:t>v3: the direct await returns. Inspect all three on the timeline.</a:t>
+              <a:t>v2 · pairDevice</a:t>
             </a:r>
           </a:p>
+        </p:txBody>
+      </p:sp>
+      <p:sp>
+        <p:nvSpPr>
+          <p:cNvPr id="128" name="TextBox 127"/>
+          <p:cNvSpPr txBox="1"/>
+          <p:nvPr/>
+        </p:nvSpPr>
+        <p:spPr>
+          <a:xfrm>
+            <a:off x="4818888" y="2633472"/>
+            <a:ext cx="3063240" cy="292608"/>
+          </a:xfrm>
+          <a:prstGeom prst="rect">
+            <a:avLst/>
+          </a:prstGeom>
+          <a:noFill/>
+        </p:spPr>
+        <p:txBody>
+          <a:bodyPr wrap="square" lIns="36576" rIns="36576" tIns="18288" bIns="18288" anchor="ctr">
+            <a:spAutoFit/>
+          </a:bodyPr>
+          <a:lstStyle/>
           <a:p>
-            <a:pPr>
-              <a:buNone/>
-              <a:spcAft>
-                <a:spcPts val="1200"/>
-              </a:spcAft>
-            </a:pPr>
             <a:r>
-              <a:rPr lang="en-US" sz="2200">
+              <a:rPr sz="1200" b="0">
                 <a:solidFill>
                   <a:srgbClr val="24243B"/>
+                </a:solidFill>
+                <a:latin typeface="Consolas"/>
+              </a:rPr>
+              <a:t>policyCheck()  ·  flows/pair.js</a:t>
+            </a:r>
+          </a:p>
+        </p:txBody>
+      </p:sp>
+      <p:sp>
+        <p:nvSpPr>
+          <p:cNvPr id="129" name="TextBox 128"/>
+          <p:cNvSpPr txBox="1"/>
+          <p:nvPr/>
+        </p:nvSpPr>
+        <p:spPr>
+          <a:xfrm>
+            <a:off x="8119871" y="2414016"/>
+            <a:ext cx="292608" cy="347472"/>
+          </a:xfrm>
+          <a:prstGeom prst="rect">
+            <a:avLst/>
+          </a:prstGeom>
+          <a:noFill/>
+        </p:spPr>
+        <p:txBody>
+          <a:bodyPr wrap="square" lIns="36576" rIns="36576" tIns="18288" bIns="18288" anchor="ctr">
+            <a:spAutoFit/>
+          </a:bodyPr>
+          <a:lstStyle/>
+          <a:p>
+            <a:r>
+              <a:rPr sz="2000" b="1">
+                <a:solidFill>
+                  <a:srgbClr val="6546CF"/>
                 </a:solidFill>
                 <a:latin typeface="Aptos"/>
               </a:rPr>
-              <a:t>Open policyCheck through its resolved local import.</a:t>
+              <a:t>→</a:t>
             </a:r>
           </a:p>
+        </p:txBody>
+      </p:sp>
+      <p:sp>
+        <p:nvSpPr>
+          <p:cNvPr id="130" name="Rounded Rectangle 129"/>
+          <p:cNvSpPr/>
+          <p:nvPr/>
+        </p:nvSpPr>
+        <p:spPr>
+          <a:xfrm>
+            <a:off x="8476488" y="2130552"/>
+            <a:ext cx="3383280" cy="987552"/>
+          </a:xfrm>
+          <a:prstGeom prst="roundRect">
+            <a:avLst/>
+          </a:prstGeom>
+          <a:solidFill>
+            <a:srgbClr val="EAF8F2"/>
+          </a:solidFill>
+          <a:ln>
+            <a:solidFill>
+              <a:srgbClr val="E2DDEF"/>
+            </a:solidFill>
+          </a:ln>
+        </p:spPr>
+        <p:style>
+          <a:lnRef idx="1">
+            <a:schemeClr val="accent1"/>
+          </a:lnRef>
+          <a:fillRef idx="3">
+            <a:schemeClr val="accent1"/>
+          </a:fillRef>
+          <a:effectRef idx="2">
+            <a:schemeClr val="accent1"/>
+          </a:effectRef>
+          <a:fontRef idx="minor">
+            <a:schemeClr val="lt1"/>
+          </a:fontRef>
+        </p:style>
+        <p:txBody>
+          <a:bodyPr rtlCol="0" anchor="ctr"/>
+          <a:lstStyle/>
           <a:p>
-            <a:pPr>
-              <a:buNone/>
-              <a:spcAft>
-                <a:spcPts val="1200"/>
-              </a:spcAft>
-            </a:pPr>
+            <a:pPr algn="ctr"/>
+          </a:p>
+        </p:txBody>
+      </p:sp>
+      <p:sp>
+        <p:nvSpPr>
+          <p:cNvPr id="131" name="TextBox 130"/>
+          <p:cNvSpPr txBox="1"/>
+          <p:nvPr/>
+        </p:nvSpPr>
+        <p:spPr>
+          <a:xfrm>
+            <a:off x="8641080" y="2258568"/>
+            <a:ext cx="3035808" cy="256032"/>
+          </a:xfrm>
+          <a:prstGeom prst="rect">
+            <a:avLst/>
+          </a:prstGeom>
+          <a:noFill/>
+        </p:spPr>
+        <p:txBody>
+          <a:bodyPr wrap="square" lIns="36576" rIns="36576" tIns="18288" bIns="18288" anchor="ctr">
+            <a:spAutoFit/>
+          </a:bodyPr>
+          <a:lstStyle/>
+          <a:p>
             <a:r>
-              <a:rPr lang="en-US" sz="2200">
+              <a:rPr sz="1700" b="1">
                 <a:solidFill>
                   <a:srgbClr val="24243B"/>
                 </a:solidFill>
                 <a:latin typeface="Aptos"/>
               </a:rPr>
-              <a:t>Video link — [TEAM TO RECORD, maximum 5 minutes]</a:t>
+              <a:t>v3 · pairDevice</a:t>
+            </a:r>
+          </a:p>
+        </p:txBody>
+      </p:sp>
+      <p:sp>
+        <p:nvSpPr>
+          <p:cNvPr id="132" name="TextBox 131"/>
+          <p:cNvSpPr txBox="1"/>
+          <p:nvPr/>
+        </p:nvSpPr>
+        <p:spPr>
+          <a:xfrm>
+            <a:off x="8641080" y="2633472"/>
+            <a:ext cx="3063240" cy="292608"/>
+          </a:xfrm>
+          <a:prstGeom prst="rect">
+            <a:avLst/>
+          </a:prstGeom>
+          <a:noFill/>
+        </p:spPr>
+        <p:txBody>
+          <a:bodyPr wrap="square" lIns="36576" rIns="36576" tIns="18288" bIns="18288" anchor="ctr">
+            <a:spAutoFit/>
+          </a:bodyPr>
+          <a:lstStyle/>
+          <a:p>
+            <a:r>
+              <a:rPr sz="1200" b="0">
+                <a:solidFill>
+                  <a:srgbClr val="24243B"/>
+                </a:solidFill>
+                <a:latin typeface="Consolas"/>
+              </a:rPr>
+              <a:t>await policyCheck()  ·  flows/pair.js</a:t>
+            </a:r>
+          </a:p>
+        </p:txBody>
+      </p:sp>
+      <p:sp>
+        <p:nvSpPr>
+          <p:cNvPr id="133" name="Rounded Rectangle 132"/>
+          <p:cNvSpPr/>
+          <p:nvPr/>
+        </p:nvSpPr>
+        <p:spPr>
+          <a:xfrm>
+            <a:off x="832104" y="3438144"/>
+            <a:ext cx="5047488" cy="1344168"/>
+          </a:xfrm>
+          <a:prstGeom prst="roundRect">
+            <a:avLst/>
+          </a:prstGeom>
+          <a:solidFill>
+            <a:srgbClr val="F8F6FD"/>
+          </a:solidFill>
+          <a:ln>
+            <a:solidFill>
+              <a:srgbClr val="E2DDEF"/>
+            </a:solidFill>
+          </a:ln>
+        </p:spPr>
+        <p:style>
+          <a:lnRef idx="1">
+            <a:schemeClr val="accent1"/>
+          </a:lnRef>
+          <a:fillRef idx="3">
+            <a:schemeClr val="accent1"/>
+          </a:fillRef>
+          <a:effectRef idx="2">
+            <a:schemeClr val="accent1"/>
+          </a:effectRef>
+          <a:fontRef idx="minor">
+            <a:schemeClr val="lt1"/>
+          </a:fontRef>
+        </p:style>
+        <p:txBody>
+          <a:bodyPr rtlCol="0" anchor="ctr"/>
+          <a:lstStyle/>
+          <a:p>
+            <a:pPr algn="ctr"/>
+          </a:p>
+        </p:txBody>
+      </p:sp>
+      <p:sp>
+        <p:nvSpPr>
+          <p:cNvPr id="134" name="Rounded Rectangle 133"/>
+          <p:cNvSpPr/>
+          <p:nvPr/>
+        </p:nvSpPr>
+        <p:spPr>
+          <a:xfrm>
+            <a:off x="6190488" y="3438144"/>
+            <a:ext cx="5047488" cy="1344168"/>
+          </a:xfrm>
+          <a:prstGeom prst="roundRect">
+            <a:avLst/>
+          </a:prstGeom>
+          <a:solidFill>
+            <a:srgbClr val="F8F6FD"/>
+          </a:solidFill>
+          <a:ln>
+            <a:solidFill>
+              <a:srgbClr val="E2DDEF"/>
+            </a:solidFill>
+          </a:ln>
+        </p:spPr>
+        <p:style>
+          <a:lnRef idx="1">
+            <a:schemeClr val="accent1"/>
+          </a:lnRef>
+          <a:fillRef idx="3">
+            <a:schemeClr val="accent1"/>
+          </a:fillRef>
+          <a:effectRef idx="2">
+            <a:schemeClr val="accent1"/>
+          </a:effectRef>
+          <a:fontRef idx="minor">
+            <a:schemeClr val="lt1"/>
+          </a:fontRef>
+        </p:style>
+        <p:txBody>
+          <a:bodyPr rtlCol="0" anchor="ctr"/>
+          <a:lstStyle/>
+          <a:p>
+            <a:pPr algn="ctr"/>
+          </a:p>
+        </p:txBody>
+      </p:sp>
+      <p:sp>
+        <p:nvSpPr>
+          <p:cNvPr id="135" name="TextBox 134"/>
+          <p:cNvSpPr txBox="1"/>
+          <p:nvPr/>
+        </p:nvSpPr>
+        <p:spPr>
+          <a:xfrm>
+            <a:off x="1014984" y="3557016"/>
+            <a:ext cx="4480560" cy="256032"/>
+          </a:xfrm>
+          <a:prstGeom prst="rect">
+            <a:avLst/>
+          </a:prstGeom>
+          <a:noFill/>
+        </p:spPr>
+        <p:txBody>
+          <a:bodyPr wrap="square" lIns="36576" rIns="36576" tIns="18288" bIns="18288" anchor="ctr">
+            <a:spAutoFit/>
+          </a:bodyPr>
+          <a:lstStyle/>
+          <a:p>
+            <a:r>
+              <a:rPr sz="1300" b="1">
+                <a:solidFill>
+                  <a:srgbClr val="6546CF"/>
+                </a:solidFill>
+                <a:latin typeface="Aptos"/>
+              </a:rPr>
+              <a:t>MATCH · v2</a:t>
+            </a:r>
+          </a:p>
+        </p:txBody>
+      </p:sp>
+      <p:sp>
+        <p:nvSpPr>
+          <p:cNvPr id="136" name="TextBox 135"/>
+          <p:cNvSpPr txBox="1"/>
+          <p:nvPr/>
+        </p:nvSpPr>
+        <p:spPr>
+          <a:xfrm>
+            <a:off x="1014984" y="3904487"/>
+            <a:ext cx="4572000" cy="594360"/>
+          </a:xfrm>
+          <a:prstGeom prst="rect">
+            <a:avLst/>
+          </a:prstGeom>
+          <a:noFill/>
+        </p:spPr>
+        <p:txBody>
+          <a:bodyPr wrap="square" lIns="36576" rIns="36576" tIns="18288" bIns="18288" anchor="ctr">
+            <a:spAutoFit/>
+          </a:bodyPr>
+          <a:lstStyle/>
+          <a:p>
+            <a:r>
+              <a:rPr sz="1700" b="0">
+                <a:solidFill>
+                  <a:srgbClr val="24243B"/>
+                </a:solidFill>
+                <a:latin typeface="Consolas"/>
+              </a:rPr>
+              <a:t>policyCheck(device);
+return openDevice(device);</a:t>
+            </a:r>
+          </a:p>
+        </p:txBody>
+      </p:sp>
+      <p:sp>
+        <p:nvSpPr>
+          <p:cNvPr id="137" name="TextBox 136"/>
+          <p:cNvSpPr txBox="1"/>
+          <p:nvPr/>
+        </p:nvSpPr>
+        <p:spPr>
+          <a:xfrm>
+            <a:off x="6373368" y="3557016"/>
+            <a:ext cx="4480560" cy="256032"/>
+          </a:xfrm>
+          <a:prstGeom prst="rect">
+            <a:avLst/>
+          </a:prstGeom>
+          <a:noFill/>
+        </p:spPr>
+        <p:txBody>
+          <a:bodyPr wrap="square" lIns="36576" rIns="36576" tIns="18288" bIns="18288" anchor="ctr">
+            <a:spAutoFit/>
+          </a:bodyPr>
+          <a:lstStyle/>
+          <a:p>
+            <a:r>
+              <a:rPr sz="1300" b="1">
+                <a:solidFill>
+                  <a:srgbClr val="96562E"/>
+                </a:solidFill>
+                <a:latin typeface="Aptos"/>
+              </a:rPr>
+              <a:t>COUNTEREXAMPLE · v1</a:t>
+            </a:r>
+          </a:p>
+        </p:txBody>
+      </p:sp>
+      <p:sp>
+        <p:nvSpPr>
+          <p:cNvPr id="138" name="TextBox 137"/>
+          <p:cNvSpPr txBox="1"/>
+          <p:nvPr/>
+        </p:nvSpPr>
+        <p:spPr>
+          <a:xfrm>
+            <a:off x="6373368" y="3904487"/>
+            <a:ext cx="4572000" cy="594360"/>
+          </a:xfrm>
+          <a:prstGeom prst="rect">
+            <a:avLst/>
+          </a:prstGeom>
+          <a:noFill/>
+        </p:spPr>
+        <p:txBody>
+          <a:bodyPr wrap="square" lIns="36576" rIns="36576" tIns="18288" bIns="18288" anchor="ctr">
+            <a:spAutoFit/>
+          </a:bodyPr>
+          <a:lstStyle/>
+          <a:p>
+            <a:r>
+              <a:rPr sz="1700" b="0">
+                <a:solidFill>
+                  <a:srgbClr val="24243B"/>
+                </a:solidFill>
+                <a:latin typeface="Consolas"/>
+              </a:rPr>
+              <a:t>await policyCheck(device);
+return openDevice(device);</a:t>
+            </a:r>
+          </a:p>
+        </p:txBody>
+      </p:sp>
+      <p:sp>
+        <p:nvSpPr>
+          <p:cNvPr id="139" name="TextBox 138"/>
+          <p:cNvSpPr txBox="1"/>
+          <p:nvPr/>
+        </p:nvSpPr>
+        <p:spPr>
+          <a:xfrm>
+            <a:off x="832104" y="5029200"/>
+            <a:ext cx="10515600" cy="640080"/>
+          </a:xfrm>
+          <a:prstGeom prst="rect">
+            <a:avLst/>
+          </a:prstGeom>
+          <a:noFill/>
+        </p:spPr>
+        <p:txBody>
+          <a:bodyPr wrap="square" lIns="36576" rIns="36576" tIns="18288" bIns="18288" anchor="ctr">
+            <a:spAutoFit/>
+          </a:bodyPr>
+          <a:lstStyle/>
+          <a:p>
+            <a:r>
+              <a:rPr sz="1700" b="0">
+                <a:solidFill>
+                  <a:srgbClr val="24243B"/>
+                </a:solidFill>
+                <a:latin typeface="Aptos"/>
+              </a:rPr>
+              <a:t>Click the timeline to inspect exact source. Follow the imported policyCheck helper. Static evidence does not prove a runtime race.</a:t>
+            </a:r>
+          </a:p>
+        </p:txBody>
+      </p:sp>
+      <p:sp>
+        <p:nvSpPr>
+          <p:cNvPr id="140" name="TextBox 139"/>
+          <p:cNvSpPr txBox="1"/>
+          <p:nvPr/>
+        </p:nvSpPr>
+        <p:spPr>
+          <a:xfrm>
+            <a:off x="832104" y="5705856"/>
+            <a:ext cx="10515600" cy="329184"/>
+          </a:xfrm>
+          <a:prstGeom prst="rect">
+            <a:avLst/>
+          </a:prstGeom>
+          <a:noFill/>
+        </p:spPr>
+        <p:txBody>
+          <a:bodyPr wrap="square" lIns="36576" rIns="36576" tIns="18288" bIns="18288" anchor="ctr">
+            <a:spAutoFit/>
+          </a:bodyPr>
+          <a:lstStyle/>
+          <a:p>
+            <a:r>
+              <a:rPr sz="1300" b="1">
+                <a:solidFill>
+                  <a:srgbClr val="6546CF"/>
+                </a:solidFill>
+                <a:latin typeface="Aptos"/>
+              </a:rPr>
+              <a:t>Video URL: [TEAM TO ADD AFTER RECORDING · 5 MIN MAX]</a:t>
             </a:r>
           </a:p>
         </p:txBody>
@@ -15256,106 +16281,615 @@
             <a:normAutofit/>
           </a:bodyPr>
           <a:lstStyle/>
+        </p:txBody>
+      </p:sp>
+      <p:sp>
+        <p:nvSpPr>
+          <p:cNvPr id="139" name="Rounded Rectangle 138"/>
+          <p:cNvSpPr/>
+          <p:nvPr/>
+        </p:nvSpPr>
+        <p:spPr>
+          <a:xfrm>
+            <a:off x="822960" y="1828800"/>
+            <a:ext cx="3465576" cy="2514600"/>
+          </a:xfrm>
+          <a:prstGeom prst="roundRect">
+            <a:avLst/>
+          </a:prstGeom>
+          <a:solidFill>
+            <a:srgbClr val="F0EBFF"/>
+          </a:solidFill>
+          <a:ln>
+            <a:solidFill>
+              <a:srgbClr val="E2DDEF"/>
+            </a:solidFill>
+          </a:ln>
+        </p:spPr>
+        <p:style>
+          <a:lnRef idx="1">
+            <a:schemeClr val="accent1"/>
+          </a:lnRef>
+          <a:fillRef idx="3">
+            <a:schemeClr val="accent1"/>
+          </a:fillRef>
+          <a:effectRef idx="2">
+            <a:schemeClr val="accent1"/>
+          </a:effectRef>
+          <a:fontRef idx="minor">
+            <a:schemeClr val="lt1"/>
+          </a:fontRef>
+        </p:style>
+        <p:txBody>
+          <a:bodyPr rtlCol="0" anchor="ctr"/>
+          <a:lstStyle/>
           <a:p>
-            <a:pPr>
-              <a:buNone/>
-              <a:spcAft>
-                <a:spcPts val="1200"/>
-              </a:spcAft>
-            </a:pPr>
+            <a:pPr algn="ctr"/>
+          </a:p>
+        </p:txBody>
+      </p:sp>
+      <p:sp>
+        <p:nvSpPr>
+          <p:cNvPr id="140" name="TextBox 139"/>
+          <p:cNvSpPr txBox="1"/>
+          <p:nvPr/>
+        </p:nvSpPr>
+        <p:spPr>
+          <a:xfrm>
+            <a:off x="987552" y="1975104"/>
+            <a:ext cx="3127248" cy="292608"/>
+          </a:xfrm>
+          <a:prstGeom prst="rect">
+            <a:avLst/>
+          </a:prstGeom>
+          <a:noFill/>
+        </p:spPr>
+        <p:txBody>
+          <a:bodyPr wrap="square" lIns="36576" rIns="36576" tIns="18288" bIns="18288" anchor="ctr">
+            <a:spAutoFit/>
+          </a:bodyPr>
+          <a:lstStyle/>
+          <a:p>
             <a:r>
-              <a:rPr lang="en-US" sz="2200">
-                <a:solidFill>
-                  <a:srgbClr val="24243B"/>
+              <a:rPr sz="1300" b="1">
+                <a:solidFill>
+                  <a:srgbClr val="6546CF"/>
                 </a:solidFill>
                 <a:latin typeface="Aptos"/>
               </a:rPr>
-              <a:t>Controlled development: 8/8 correct top results, 1,025 snippets.</a:t>
+              <a:t>CONTROLLED VERSIONS</a:t>
             </a:r>
           </a:p>
+        </p:txBody>
+      </p:sp>
+      <p:sp>
+        <p:nvSpPr>
+          <p:cNvPr id="141" name="TextBox 140"/>
+          <p:cNvSpPr txBox="1"/>
+          <p:nvPr/>
+        </p:nvSpPr>
+        <p:spPr>
+          <a:xfrm>
+            <a:off x="987552" y="2331720"/>
+            <a:ext cx="3127248" cy="694944"/>
+          </a:xfrm>
+          <a:prstGeom prst="rect">
+            <a:avLst/>
+          </a:prstGeom>
+          <a:noFill/>
+        </p:spPr>
+        <p:txBody>
+          <a:bodyPr wrap="square" lIns="36576" rIns="36576" tIns="18288" bIns="18288" anchor="ctr">
+            <a:spAutoFit/>
+          </a:bodyPr>
+          <a:lstStyle/>
           <a:p>
-            <a:pPr>
-              <a:buNone/>
-              <a:spcAft>
-                <a:spcPts val="1200"/>
-              </a:spcAft>
-            </a:pPr>
             <a:r>
-              <a:rPr lang="en-US" sz="2200">
+              <a:rPr sz="3600" b="1">
                 <a:solidFill>
                   <a:srgbClr val="24243B"/>
                 </a:solidFill>
                 <a:latin typeface="Aptos"/>
               </a:rPr>
-              <a:t>60 frozen source-reviewed queries: Async + Express.</a:t>
+              <a:t>8 / 8</a:t>
             </a:r>
           </a:p>
+        </p:txBody>
+      </p:sp>
+      <p:sp>
+        <p:nvSpPr>
+          <p:cNvPr id="142" name="TextBox 141"/>
+          <p:cNvSpPr txBox="1"/>
+          <p:nvPr/>
+        </p:nvSpPr>
+        <p:spPr>
+          <a:xfrm>
+            <a:off x="987552" y="3136392"/>
+            <a:ext cx="3127248" cy="393192"/>
+          </a:xfrm>
+          <a:prstGeom prst="rect">
+            <a:avLst/>
+          </a:prstGeom>
+          <a:noFill/>
+        </p:spPr>
+        <p:txBody>
+          <a:bodyPr wrap="square" lIns="36576" rIns="36576" tIns="18288" bIns="18288" anchor="ctr">
+            <a:spAutoFit/>
+          </a:bodyPr>
+          <a:lstStyle/>
           <a:p>
-            <a:pPr>
-              <a:buNone/>
-              <a:spcAft>
-                <a:spcPts val="1200"/>
-              </a:spcAft>
-            </a:pPr>
             <a:r>
-              <a:rPr lang="en-US" sz="2200">
+              <a:rPr sz="1600" b="0">
                 <a:solidFill>
                   <a:srgbClr val="24243B"/>
                 </a:solidFill>
                 <a:latin typeface="Aptos"/>
               </a:rPr>
-              <a:t>BGE hybrid NDCG@10: Async 0.6717; Express 0.8577.</a:t>
+              <a:t>correct top result</a:t>
             </a:r>
           </a:p>
+        </p:txBody>
+      </p:sp>
+      <p:sp>
+        <p:nvSpPr>
+          <p:cNvPr id="143" name="TextBox 142"/>
+          <p:cNvSpPr txBox="1"/>
+          <p:nvPr/>
+        </p:nvSpPr>
+        <p:spPr>
+          <a:xfrm>
+            <a:off x="987552" y="3730752"/>
+            <a:ext cx="3127248" cy="438912"/>
+          </a:xfrm>
+          <a:prstGeom prst="rect">
+            <a:avLst/>
+          </a:prstGeom>
+          <a:noFill/>
+        </p:spPr>
+        <p:txBody>
+          <a:bodyPr wrap="square" lIns="36576" rIns="36576" tIns="18288" bIns="18288" anchor="ctr">
+            <a:spAutoFit/>
+          </a:bodyPr>
+          <a:lstStyle/>
           <a:p>
-            <a:pPr>
-              <a:buNone/>
-              <a:spcAft>
-                <a:spcPts val="1200"/>
-              </a:spcAft>
-            </a:pPr>
             <a:r>
-              <a:rPr lang="en-US" sz="2200">
+              <a:rPr sz="1100" b="0">
                 <a:solidFill>
                   <a:srgbClr val="24243B"/>
                 </a:solidFill>
                 <a:latin typeface="Aptos"/>
               </a:rPr>
-              <a:t>Official AppsRetrieval: NDCG@10 0.0505; MRR@10 0.043363.</a:t>
+              <a:t>25 demo snippets + 1,000 distractors</a:t>
             </a:r>
           </a:p>
+        </p:txBody>
+      </p:sp>
+      <p:sp>
+        <p:nvSpPr>
+          <p:cNvPr id="144" name="Rounded Rectangle 143"/>
+          <p:cNvSpPr/>
+          <p:nvPr/>
+        </p:nvSpPr>
+        <p:spPr>
+          <a:xfrm>
+            <a:off x="4645152" y="1828800"/>
+            <a:ext cx="3465576" cy="2514600"/>
+          </a:xfrm>
+          <a:prstGeom prst="roundRect">
+            <a:avLst/>
+          </a:prstGeom>
+          <a:solidFill>
+            <a:srgbClr val="EAF8F2"/>
+          </a:solidFill>
+          <a:ln>
+            <a:solidFill>
+              <a:srgbClr val="E2DDEF"/>
+            </a:solidFill>
+          </a:ln>
+        </p:spPr>
+        <p:style>
+          <a:lnRef idx="1">
+            <a:schemeClr val="accent1"/>
+          </a:lnRef>
+          <a:fillRef idx="3">
+            <a:schemeClr val="accent1"/>
+          </a:fillRef>
+          <a:effectRef idx="2">
+            <a:schemeClr val="accent1"/>
+          </a:effectRef>
+          <a:fontRef idx="minor">
+            <a:schemeClr val="lt1"/>
+          </a:fontRef>
+        </p:style>
+        <p:txBody>
+          <a:bodyPr rtlCol="0" anchor="ctr"/>
+          <a:lstStyle/>
           <a:p>
-            <a:pPr>
-              <a:buNone/>
-              <a:spcAft>
-                <a:spcPts val="1200"/>
-              </a:spcAft>
-            </a:pPr>
+            <a:pPr algn="ctr"/>
+          </a:p>
+        </p:txBody>
+      </p:sp>
+      <p:sp>
+        <p:nvSpPr>
+          <p:cNvPr id="145" name="TextBox 144"/>
+          <p:cNvSpPr txBox="1"/>
+          <p:nvPr/>
+        </p:nvSpPr>
+        <p:spPr>
+          <a:xfrm>
+            <a:off x="4809744" y="1975104"/>
+            <a:ext cx="3127248" cy="292608"/>
+          </a:xfrm>
+          <a:prstGeom prst="rect">
+            <a:avLst/>
+          </a:prstGeom>
+          <a:noFill/>
+        </p:spPr>
+        <p:txBody>
+          <a:bodyPr wrap="square" lIns="36576" rIns="36576" tIns="18288" bIns="18288" anchor="ctr">
+            <a:spAutoFit/>
+          </a:bodyPr>
+          <a:lstStyle/>
+          <a:p>
             <a:r>
-              <a:rPr lang="en-US" sz="2200">
-                <a:solidFill>
-                  <a:srgbClr val="24243B"/>
+              <a:rPr sz="1300" b="1">
+                <a:solidFill>
+                  <a:srgbClr val="6546CF"/>
                 </a:solidFill>
                 <a:latin typeface="Aptos"/>
               </a:rPr>
-              <a:t>Official screening accuracy is weak; not a competitive claim.</a:t>
+              <a:t>REAL CODE</a:t>
             </a:r>
           </a:p>
+        </p:txBody>
+      </p:sp>
+      <p:sp>
+        <p:nvSpPr>
+          <p:cNvPr id="146" name="TextBox 145"/>
+          <p:cNvSpPr txBox="1"/>
+          <p:nvPr/>
+        </p:nvSpPr>
+        <p:spPr>
+          <a:xfrm>
+            <a:off x="4809744" y="2331720"/>
+            <a:ext cx="3127248" cy="694944"/>
+          </a:xfrm>
+          <a:prstGeom prst="rect">
+            <a:avLst/>
+          </a:prstGeom>
+          <a:noFill/>
+        </p:spPr>
+        <p:txBody>
+          <a:bodyPr wrap="square" lIns="36576" rIns="36576" tIns="18288" bIns="18288" anchor="ctr">
+            <a:spAutoFit/>
+          </a:bodyPr>
+          <a:lstStyle/>
           <a:p>
-            <a:pPr>
-              <a:buNone/>
-              <a:spcAft>
-                <a:spcPts val="1200"/>
-              </a:spcAft>
-            </a:pPr>
             <a:r>
-              <a:rPr lang="en-US" sz="2200">
+              <a:rPr sz="3600" b="1">
                 <a:solidFill>
                   <a:srgbClr val="24243B"/>
                 </a:solidFill>
                 <a:latin typeface="Aptos"/>
               </a:rPr>
-              <a:t>AI-assisted labels, small corpora, heuristic lineage, bounded syntax.</a:t>
+              <a:t>0.67 / 0.86</a:t>
+            </a:r>
+          </a:p>
+        </p:txBody>
+      </p:sp>
+      <p:sp>
+        <p:nvSpPr>
+          <p:cNvPr id="147" name="TextBox 146"/>
+          <p:cNvSpPr txBox="1"/>
+          <p:nvPr/>
+        </p:nvSpPr>
+        <p:spPr>
+          <a:xfrm>
+            <a:off x="4809744" y="3136392"/>
+            <a:ext cx="3127248" cy="393192"/>
+          </a:xfrm>
+          <a:prstGeom prst="rect">
+            <a:avLst/>
+          </a:prstGeom>
+          <a:noFill/>
+        </p:spPr>
+        <p:txBody>
+          <a:bodyPr wrap="square" lIns="36576" rIns="36576" tIns="18288" bIns="18288" anchor="ctr">
+            <a:spAutoFit/>
+          </a:bodyPr>
+          <a:lstStyle/>
+          <a:p>
+            <a:r>
+              <a:rPr sz="1600" b="0">
+                <a:solidFill>
+                  <a:srgbClr val="24243B"/>
+                </a:solidFill>
+                <a:latin typeface="Aptos"/>
+              </a:rPr>
+              <a:t>NDCG@10, Async / Express</a:t>
+            </a:r>
+          </a:p>
+        </p:txBody>
+      </p:sp>
+      <p:sp>
+        <p:nvSpPr>
+          <p:cNvPr id="148" name="TextBox 147"/>
+          <p:cNvSpPr txBox="1"/>
+          <p:nvPr/>
+        </p:nvSpPr>
+        <p:spPr>
+          <a:xfrm>
+            <a:off x="4809744" y="3730752"/>
+            <a:ext cx="3127248" cy="438912"/>
+          </a:xfrm>
+          <a:prstGeom prst="rect">
+            <a:avLst/>
+          </a:prstGeom>
+          <a:noFill/>
+        </p:spPr>
+        <p:txBody>
+          <a:bodyPr wrap="square" lIns="36576" rIns="36576" tIns="18288" bIns="18288" anchor="ctr">
+            <a:spAutoFit/>
+          </a:bodyPr>
+          <a:lstStyle/>
+          <a:p>
+            <a:r>
+              <a:rPr sz="1100" b="0">
+                <a:solidFill>
+                  <a:srgbClr val="24243B"/>
+                </a:solidFill>
+                <a:latin typeface="Aptos"/>
+              </a:rPr>
+              <a:t>60 AI-assisted, source-reviewed labels</a:t>
+            </a:r>
+          </a:p>
+        </p:txBody>
+      </p:sp>
+      <p:sp>
+        <p:nvSpPr>
+          <p:cNvPr id="149" name="Rounded Rectangle 148"/>
+          <p:cNvSpPr/>
+          <p:nvPr/>
+        </p:nvSpPr>
+        <p:spPr>
+          <a:xfrm>
+            <a:off x="8467344" y="1828800"/>
+            <a:ext cx="3465576" cy="2514600"/>
+          </a:xfrm>
+          <a:prstGeom prst="roundRect">
+            <a:avLst/>
+          </a:prstGeom>
+          <a:solidFill>
+            <a:srgbClr val="FFF2E5"/>
+          </a:solidFill>
+          <a:ln>
+            <a:solidFill>
+              <a:srgbClr val="E2DDEF"/>
+            </a:solidFill>
+          </a:ln>
+        </p:spPr>
+        <p:style>
+          <a:lnRef idx="1">
+            <a:schemeClr val="accent1"/>
+          </a:lnRef>
+          <a:fillRef idx="3">
+            <a:schemeClr val="accent1"/>
+          </a:fillRef>
+          <a:effectRef idx="2">
+            <a:schemeClr val="accent1"/>
+          </a:effectRef>
+          <a:fontRef idx="minor">
+            <a:schemeClr val="lt1"/>
+          </a:fontRef>
+        </p:style>
+        <p:txBody>
+          <a:bodyPr rtlCol="0" anchor="ctr"/>
+          <a:lstStyle/>
+          <a:p>
+            <a:pPr algn="ctr"/>
+          </a:p>
+        </p:txBody>
+      </p:sp>
+      <p:sp>
+        <p:nvSpPr>
+          <p:cNvPr id="150" name="TextBox 149"/>
+          <p:cNvSpPr txBox="1"/>
+          <p:nvPr/>
+        </p:nvSpPr>
+        <p:spPr>
+          <a:xfrm>
+            <a:off x="8631936" y="1975104"/>
+            <a:ext cx="3127248" cy="292608"/>
+          </a:xfrm>
+          <a:prstGeom prst="rect">
+            <a:avLst/>
+          </a:prstGeom>
+          <a:noFill/>
+        </p:spPr>
+        <p:txBody>
+          <a:bodyPr wrap="square" lIns="36576" rIns="36576" tIns="18288" bIns="18288" anchor="ctr">
+            <a:spAutoFit/>
+          </a:bodyPr>
+          <a:lstStyle/>
+          <a:p>
+            <a:r>
+              <a:rPr sz="1300" b="1">
+                <a:solidFill>
+                  <a:srgbClr val="6546CF"/>
+                </a:solidFill>
+                <a:latin typeface="Aptos"/>
+              </a:rPr>
+              <a:t>OFFICIAL SCREENING</a:t>
+            </a:r>
+          </a:p>
+        </p:txBody>
+      </p:sp>
+      <p:sp>
+        <p:nvSpPr>
+          <p:cNvPr id="151" name="TextBox 150"/>
+          <p:cNvSpPr txBox="1"/>
+          <p:nvPr/>
+        </p:nvSpPr>
+        <p:spPr>
+          <a:xfrm>
+            <a:off x="8631936" y="2331720"/>
+            <a:ext cx="3127248" cy="694944"/>
+          </a:xfrm>
+          <a:prstGeom prst="rect">
+            <a:avLst/>
+          </a:prstGeom>
+          <a:noFill/>
+        </p:spPr>
+        <p:txBody>
+          <a:bodyPr wrap="square" lIns="36576" rIns="36576" tIns="18288" bIns="18288" anchor="ctr">
+            <a:spAutoFit/>
+          </a:bodyPr>
+          <a:lstStyle/>
+          <a:p>
+            <a:r>
+              <a:rPr sz="3600" b="1">
+                <a:solidFill>
+                  <a:srgbClr val="24243B"/>
+                </a:solidFill>
+                <a:latin typeface="Aptos"/>
+              </a:rPr>
+              <a:t>0.0505</a:t>
+            </a:r>
+          </a:p>
+        </p:txBody>
+      </p:sp>
+      <p:sp>
+        <p:nvSpPr>
+          <p:cNvPr id="152" name="TextBox 151"/>
+          <p:cNvSpPr txBox="1"/>
+          <p:nvPr/>
+        </p:nvSpPr>
+        <p:spPr>
+          <a:xfrm>
+            <a:off x="8631936" y="3136392"/>
+            <a:ext cx="3127248" cy="393192"/>
+          </a:xfrm>
+          <a:prstGeom prst="rect">
+            <a:avLst/>
+          </a:prstGeom>
+          <a:noFill/>
+        </p:spPr>
+        <p:txBody>
+          <a:bodyPr wrap="square" lIns="36576" rIns="36576" tIns="18288" bIns="18288" anchor="ctr">
+            <a:spAutoFit/>
+          </a:bodyPr>
+          <a:lstStyle/>
+          <a:p>
+            <a:r>
+              <a:rPr sz="1600" b="0">
+                <a:solidFill>
+                  <a:srgbClr val="24243B"/>
+                </a:solidFill>
+                <a:latin typeface="Aptos"/>
+              </a:rPr>
+              <a:t>AppsRetrieval NDCG@10</a:t>
+            </a:r>
+          </a:p>
+        </p:txBody>
+      </p:sp>
+      <p:sp>
+        <p:nvSpPr>
+          <p:cNvPr id="153" name="TextBox 152"/>
+          <p:cNvSpPr txBox="1"/>
+          <p:nvPr/>
+        </p:nvSpPr>
+        <p:spPr>
+          <a:xfrm>
+            <a:off x="8631936" y="3730752"/>
+            <a:ext cx="3127248" cy="438912"/>
+          </a:xfrm>
+          <a:prstGeom prst="rect">
+            <a:avLst/>
+          </a:prstGeom>
+          <a:noFill/>
+        </p:spPr>
+        <p:txBody>
+          <a:bodyPr wrap="square" lIns="36576" rIns="36576" tIns="18288" bIns="18288" anchor="ctr">
+            <a:spAutoFit/>
+          </a:bodyPr>
+          <a:lstStyle/>
+          <a:p>
+            <a:r>
+              <a:rPr sz="1100" b="0">
+                <a:solidFill>
+                  <a:srgbClr val="24243B"/>
+                </a:solidFill>
+                <a:latin typeface="Aptos"/>
+              </a:rPr>
+              <a:t>weak baseline · improvement required</a:t>
+            </a:r>
+          </a:p>
+        </p:txBody>
+      </p:sp>
+      <p:sp>
+        <p:nvSpPr>
+          <p:cNvPr id="154" name="TextBox 153"/>
+          <p:cNvSpPr txBox="1"/>
+          <p:nvPr/>
+        </p:nvSpPr>
+        <p:spPr>
+          <a:xfrm>
+            <a:off x="832104" y="4681728"/>
+            <a:ext cx="10515600" cy="603504"/>
+          </a:xfrm>
+          <a:prstGeom prst="rect">
+            <a:avLst/>
+          </a:prstGeom>
+          <a:noFill/>
+        </p:spPr>
+        <p:txBody>
+          <a:bodyPr wrap="square" lIns="36576" rIns="36576" tIns="18288" bIns="18288" anchor="ctr">
+            <a:spAutoFit/>
+          </a:bodyPr>
+          <a:lstStyle/>
+          <a:p>
+            <a:r>
+              <a:rPr sz="1700" b="0">
+                <a:solidFill>
+                  <a:srgbClr val="24243B"/>
+                </a:solidFill>
+                <a:latin typeface="Aptos"/>
+              </a:rPr>
+              <a:t>These are separate evaluations. Official MRR@10 is 0.043363. The MTEB encoder does not test version reranking.</a:t>
+            </a:r>
+          </a:p>
+        </p:txBody>
+      </p:sp>
+      <p:sp>
+        <p:nvSpPr>
+          <p:cNvPr id="155" name="TextBox 154"/>
+          <p:cNvSpPr txBox="1"/>
+          <p:nvPr/>
+        </p:nvSpPr>
+        <p:spPr>
+          <a:xfrm>
+            <a:off x="832104" y="5458968"/>
+            <a:ext cx="10515600" cy="457200"/>
+          </a:xfrm>
+          <a:prstGeom prst="rect">
+            <a:avLst/>
+          </a:prstGeom>
+          <a:noFill/>
+        </p:spPr>
+        <p:txBody>
+          <a:bodyPr wrap="square" lIns="36576" rIns="36576" tIns="18288" bIns="18288" anchor="ctr">
+            <a:spAutoFit/>
+          </a:bodyPr>
+          <a:lstStyle/>
+          <a:p>
+            <a:r>
+              <a:rPr sz="1400" b="1">
+                <a:solidFill>
+                  <a:srgbClr val="6546CF"/>
+                </a:solidFill>
+                <a:latin typeface="Aptos"/>
+              </a:rPr>
+              <a:t>Limits: heuristic lineage · bounded static syntax · no independently annotated real-code labels.</a:t>
             </a:r>
           </a:p>
         </p:txBody>

</xml_diff>

<commit_message>
Validate code-trained CPU retrieval and refresh submission assets
</commit_message>
<xml_diff>
--- a/docs/CodeStrata-Submission-Draft.pptx
+++ b/docs/CodeStrata-Submission-Draft.pptx
@@ -13663,7 +13663,7 @@
                 </a:solidFill>
                 <a:latin typeface="Aptos"/>
               </a:rPr>
-              <a:t>Presentation draft — YES; team details remain incomplete.</a:t>
+              <a:t>Presentation — YES; both team members and contacts entered.</a:t>
             </a:r>
           </a:p>
           <a:p>
@@ -15891,7 +15891,7 @@
                 </a:solidFill>
                 <a:latin typeface="Aptos"/>
               </a:rPr>
-              <a:t>Optional Transformers.js q8 BGE / MiniLM on CPU, two threads.</a:t>
+              <a:t>Optional CPU q8 BGE, Jina Code, or MiniLM; two threads.</a:t>
             </a:r>
           </a:p>
           <a:p>
@@ -17023,7 +17023,7 @@
                 </a:solidFill>
                 <a:latin typeface="Aptos"/>
               </a:rPr>
-              <a:t>Prioritize a code-specific encoder using separate development data.</a:t>
+              <a:t>Validate the code encoder on the full official test; keep train/test separate.</a:t>
             </a:r>
           </a:p>
           <a:p>
@@ -17108,7 +17108,7 @@
                 </a:solidFill>
                 <a:latin typeface="Aptos"/>
               </a:rPr>
-              <a:t>Finish team identity, video, disclosure, and organizer review.</a:t>
+              <a:t>Record the demo, sign disclosure, and confirm organizer submission.</a:t>
             </a:r>
           </a:p>
         </p:txBody>

</xml_diff>

<commit_message>
Tie presentation metrics to official results and add judge brief
</commit_message>
<xml_diff>
--- a/docs/CodeStrata-Submission-Draft.pptx
+++ b/docs/CodeStrata-Submission-Draft.pptx
@@ -16821,7 +16821,7 @@
                 </a:solidFill>
                 <a:latin typeface="Aptos"/>
               </a:rPr>
-              <a:t>weak baseline · improvement required</a:t>
+              <a:t>BGE q8 · full MTEB test</a:t>
             </a:r>
           </a:p>
         </p:txBody>
@@ -16855,7 +16855,7 @@
                 </a:solidFill>
                 <a:latin typeface="Aptos"/>
               </a:rPr>
-              <a:t>These are separate evaluations. Official MRR@10 is 0.043363. The MTEB encoder does not test version reranking.</a:t>
+              <a:t>BGE baseline NDCG@10 0.0505; selected MRR@10 0.0434. MTEB excludes version reranking.</a:t>
             </a:r>
           </a:p>
         </p:txBody>

</xml_diff>